<commit_message>
Update submission deck with team details
</commit_message>
<xml_diff>
--- a/submission/AesCodeNexus_Round1_Submission_Final_Technical_Patient_Deterioration_TeamReady.pptx
+++ b/submission/AesCodeNexus_Round1_Submission_Final_Technical_Patient_Deterioration_TeamReady.pptx
@@ -6339,7 +6339,7 @@
                 </a:lnSpc>
               </a:pPr>
               <a:r>
-                <a:t>[Add Team Name]</a:t>
+                <a:t>Aalam dhudh soda</a:t>
               </a:r>
             </a:p>
           </p:txBody>
@@ -6536,7 +6536,7 @@
                 </a:lnSpc>
               </a:pPr>
               <a:r>
-                <a:t>[Add Team ID]</a:t>
+                <a:t>anc-052</a:t>
               </a:r>
             </a:p>
           </p:txBody>
@@ -8514,7 +8514,7 @@
                 </a:lnSpc>
               </a:pPr>
               <a:r>
-                <a:t>Team: [Add Team Name]  |  ID: [Add Team ID]</a:t>
+                <a:t>Team: Aalam dhudh soda  |  ID: anc-052</a:t>
               </a:r>
             </a:p>
           </p:txBody>
@@ -11102,7 +11102,7 @@
                 </a:lnSpc>
               </a:pPr>
               <a:r>
-                <a:t>Team: [Add Team Name]  |  ID: [Add Team ID]</a:t>
+                <a:t>Team: Aalam dhudh soda  |  ID: anc-052</a:t>
               </a:r>
             </a:p>
           </p:txBody>
@@ -13001,7 +13001,7 @@
                 </a:lnSpc>
               </a:pPr>
               <a:r>
-                <a:t>Team: [Add Team Name]  |  ID: [Add Team ID]</a:t>
+                <a:t>Team: Aalam dhudh soda  |  ID: anc-052</a:t>
               </a:r>
             </a:p>
           </p:txBody>
@@ -18726,7 +18726,7 @@
                 </a:lnSpc>
               </a:pPr>
               <a:r>
-                <a:t>Team: [Add Team Name]  |  ID: [Add Team ID]</a:t>
+                <a:t>Team: Aalam dhudh soda  |  ID: anc-052</a:t>
               </a:r>
             </a:p>
           </p:txBody>
@@ -24319,7 +24319,7 @@
                 </a:lnSpc>
               </a:pPr>
               <a:r>
-                <a:t>Team: [Add Team Name]  |  ID: [Add Team ID]</a:t>
+                <a:t>Team: Aalam dhudh soda  |  ID: anc-052</a:t>
               </a:r>
             </a:p>
           </p:txBody>
@@ -31391,7 +31391,7 @@
                 </a:lnSpc>
               </a:pPr>
               <a:r>
-                <a:t>Team: [Add Team Name]  |  ID: [Add Team ID]</a:t>
+                <a:t>Team: Aalam dhudh soda  |  ID: anc-052</a:t>
               </a:r>
             </a:p>
           </p:txBody>
@@ -35729,7 +35729,7 @@
                 </a:lnSpc>
               </a:pPr>
               <a:r>
-                <a:t>Team: [Add Team Name]  |  ID: [Add Team ID]</a:t>
+                <a:t>Team: Aalam dhudh soda  |  ID: anc-052</a:t>
               </a:r>
             </a:p>
           </p:txBody>
@@ -35988,7 +35988,7 @@
                 </a:lnSpc>
               </a:pPr>
               <a:r>
-                <a:t>Team Name: [Add Team Name]</a:t>
+                <a:t>Team Name: Aalam dhudh soda</a:t>
               </a:r>
             </a:p>
           </p:txBody>
@@ -36082,7 +36082,7 @@
                 </a:lnSpc>
               </a:pPr>
               <a:r>
-                <a:t>Team ID: [Add Team ID]  |  Problem Statement: Patient Deterioration Prediction</a:t>
+                <a:t>Team ID: anc-052  |  Problem Statement: Patient Deterioration Prediction</a:t>
               </a:r>
             </a:p>
           </p:txBody>
@@ -40361,7 +40361,7 @@
                 </a:lnSpc>
               </a:pPr>
               <a:r>
-                <a:t>Team: [Add Team Name]  |  ID: [Add Team ID]</a:t>
+                <a:t>Team: Aalam dhudh soda  |  ID: anc-052</a:t>
               </a:r>
             </a:p>
           </p:txBody>

</xml_diff>

<commit_message>
Finalize submission deck metadata
</commit_message>
<xml_diff>
--- a/submission/AesCodeNexus_Round1_Submission_Final_Technical_Patient_Deterioration_TeamReady.pptx
+++ b/submission/AesCodeNexus_Round1_Submission_Final_Technical_Patient_Deterioration_TeamReady.pptx
@@ -6142,7 +6142,7 @@
                 </a:lnSpc>
               </a:pPr>
               <a:r>
-                <a:t>Patient Deterioration Prediction</a:t>
+                <a:t>PS 2 - Patient Deterioration Prediction</a:t>
               </a:r>
             </a:p>
           </p:txBody>
@@ -6733,7 +6733,7 @@
                 </a:lnSpc>
               </a:pPr>
               <a:r>
-                <a:t>[Add Institution]</a:t>
+                <a:t>PES UNIVERSITY, BLR</a:t>
               </a:r>
             </a:p>
           </p:txBody>
@@ -36082,7 +36082,7 @@
                 </a:lnSpc>
               </a:pPr>
               <a:r>
-                <a:t>Team ID: anc-052  |  Problem Statement: Patient Deterioration Prediction</a:t>
+                <a:t>Team ID: anc-052  |  Problem Statement: PS 2 - Patient Deterioration Prediction</a:t>
               </a:r>
             </a:p>
           </p:txBody>

</xml_diff>